<commit_message>
Trim bibliography to five scholarly entries
Removed the Multitracking the Spirit paper, the generic course
materials entry, and King et al. The remaining five sources are
the ones actually cited in the argument.

Made-with: Cursor
</commit_message>
<xml_diff>
--- a/I_Know_Who_I_Am_Presentation.pptx
+++ b/I_Know_Who_I_Am_Presentation.pptx
@@ -1097,7 +1097,7 @@
               <a:rPr sz="1200">
                 <a:latin typeface="Calibri"/>
               </a:rPr>
-              <a:t>Leave this slide up during questions. The core scholarly anchors are King et al. for the course framing and the Ajose and Ayodeji studies for Nigerian Pentecostal music specifically. Rotimi and Ajose’s prosperity gospel essay both connect directly to the practical-theology argument.</a:t>
+              <a:t>Leave this slide up during questions. The core scholarly anchors are the Ajose and Ayodeji studies on Nigerian Pentecostal music, with Rotimi and Ajose’s prosperity gospel essay both connecting directly to the practical-theology argument.</a:t>
             </a:r>
           </a:p>
         </p:txBody>
@@ -8833,14 +8833,14 @@
           <a:p>
             <a:pPr algn="l">
               <a:lnSpc>
-                <a:spcPct val="120000"/>
+                <a:spcPct val="125000"/>
               </a:lnSpc>
               <a:spcAft>
-                <a:spcPts val="400"/>
+                <a:spcPts val="600"/>
               </a:spcAft>
             </a:pPr>
             <a:r>
-              <a:rPr sz="1100" b="1">
+              <a:rPr sz="1200" b="1">
                 <a:solidFill>
                   <a:srgbClr val="8A4B2A"/>
                 </a:solidFill>
@@ -8849,26 +8849,26 @@
               <a:t>1.  </a:t>
             </a:r>
             <a:r>
-              <a:rPr sz="1200">
+              <a:rPr sz="1300">
                 <a:solidFill>
                   <a:srgbClr val="3A3630"/>
                 </a:solidFill>
                 <a:latin typeface="Georgia"/>
               </a:rPr>
-              <a:t>Ajose, Toyin. “Multitracking the Spirit: Musicality, Prayer Chants and Pentecostal Spirituality in Nigeria.” Harvard Divinity School, 2025.</a:t>
+              <a:t>Ajose, Toyin Samuel. “Liturgical traditions and transitions: Congregational hymn singing in Nigerian Pentecostal churches.” Journal of the Association of Nigerian Musicologists, 2025.</a:t>
             </a:r>
           </a:p>
           <a:p>
             <a:pPr algn="l">
               <a:lnSpc>
-                <a:spcPct val="120000"/>
+                <a:spcPct val="125000"/>
               </a:lnSpc>
               <a:spcAft>
-                <a:spcPts val="400"/>
+                <a:spcPts val="600"/>
               </a:spcAft>
             </a:pPr>
             <a:r>
-              <a:rPr sz="1100" b="1">
+              <a:rPr sz="1200" b="1">
                 <a:solidFill>
                   <a:srgbClr val="8A4B2A"/>
                 </a:solidFill>
@@ -8877,26 +8877,26 @@
               <a:t>2.  </a:t>
             </a:r>
             <a:r>
-              <a:rPr sz="1200">
+              <a:rPr sz="1300">
                 <a:solidFill>
                   <a:srgbClr val="3A3630"/>
                 </a:solidFill>
                 <a:latin typeface="Georgia"/>
               </a:rPr>
-              <a:t>Ajose, Toyin Samuel. “Liturgical traditions and transitions: Congregational hymn singing in Nigerian Pentecostal churches.” Journal of the Association of Nigerian Musicologists, 2025.</a:t>
+              <a:t>Ajose, Toyin Samuel. “‘Me I no go suffer’: Christian songs and prosperity gospel among Yoruba Pentecostals in Southwest Nigeria.”</a:t>
             </a:r>
           </a:p>
           <a:p>
             <a:pPr algn="l">
               <a:lnSpc>
-                <a:spcPct val="120000"/>
+                <a:spcPct val="125000"/>
               </a:lnSpc>
               <a:spcAft>
-                <a:spcPts val="400"/>
+                <a:spcPts val="600"/>
               </a:spcAft>
             </a:pPr>
             <a:r>
-              <a:rPr sz="1100" b="1">
+              <a:rPr sz="1200" b="1">
                 <a:solidFill>
                   <a:srgbClr val="8A4B2A"/>
                 </a:solidFill>
@@ -8905,26 +8905,26 @@
               <a:t>3.  </a:t>
             </a:r>
             <a:r>
-              <a:rPr sz="1200">
+              <a:rPr sz="1300">
                 <a:solidFill>
                   <a:srgbClr val="3A3630"/>
                 </a:solidFill>
                 <a:latin typeface="Georgia"/>
               </a:rPr>
-              <a:t>Ajose, Toyin Samuel. “‘Me I no go suffer’: Christian songs and prosperity gospel among Yoruba Pentecostals in Southwest Nigeria.”</a:t>
+              <a:t>Ayodeji, Oluwafemi Emmanuel. Ecstasy, Holiness and Spiritual Warfare: Yorùbá Pentecostal Music Experience. Durham University, 2019.</a:t>
             </a:r>
           </a:p>
           <a:p>
             <a:pPr algn="l">
               <a:lnSpc>
-                <a:spcPct val="120000"/>
+                <a:spcPct val="125000"/>
               </a:lnSpc>
               <a:spcAft>
-                <a:spcPts val="400"/>
+                <a:spcPts val="600"/>
               </a:spcAft>
             </a:pPr>
             <a:r>
-              <a:rPr sz="1100" b="1">
+              <a:rPr sz="1200" b="1">
                 <a:solidFill>
                   <a:srgbClr val="8A4B2A"/>
                 </a:solidFill>
@@ -8933,26 +8933,26 @@
               <a:t>4.  </a:t>
             </a:r>
             <a:r>
-              <a:rPr sz="1200">
+              <a:rPr sz="1300">
                 <a:solidFill>
                   <a:srgbClr val="3A3630"/>
                 </a:solidFill>
                 <a:latin typeface="Georgia"/>
               </a:rPr>
-              <a:t>Ayodeji, Oluwafemi Emmanuel. Ecstasy, Holiness and Spiritual Warfare: Yorùbá Pentecostal Music Experience. Durham University, 2019.</a:t>
+              <a:t>Rotimi, Oti Alaba. “The Role of Music in African Pentecostal Churches in Southwestern Nigeria.”</a:t>
             </a:r>
           </a:p>
           <a:p>
             <a:pPr algn="l">
               <a:lnSpc>
-                <a:spcPct val="120000"/>
+                <a:spcPct val="125000"/>
               </a:lnSpc>
               <a:spcAft>
-                <a:spcPts val="400"/>
+                <a:spcPts val="600"/>
               </a:spcAft>
             </a:pPr>
             <a:r>
-              <a:rPr sz="1100" b="1">
+              <a:rPr sz="1200" b="1">
                 <a:solidFill>
                   <a:srgbClr val="8A4B2A"/>
                 </a:solidFill>
@@ -8961,91 +8961,7 @@
               <a:t>5.  </a:t>
             </a:r>
             <a:r>
-              <a:rPr sz="1200">
-                <a:solidFill>
-                  <a:srgbClr val="3A3630"/>
-                </a:solidFill>
-                <a:latin typeface="Georgia"/>
-              </a:rPr>
-              <a:t>Course materials and lecture framing, African Urban Worship Music, Yale Divinity School.</a:t>
-            </a:r>
-          </a:p>
-          <a:p>
-            <a:pPr algn="l">
-              <a:lnSpc>
-                <a:spcPct val="120000"/>
-              </a:lnSpc>
-              <a:spcAft>
-                <a:spcPts val="400"/>
-              </a:spcAft>
-            </a:pPr>
-            <a:r>
-              <a:rPr sz="1100" b="1">
-                <a:solidFill>
-                  <a:srgbClr val="8A4B2A"/>
-                </a:solidFill>
-                <a:latin typeface="Calibri"/>
-              </a:rPr>
-              <a:t>6.  </a:t>
-            </a:r>
-            <a:r>
-              <a:rPr sz="1200">
-                <a:solidFill>
-                  <a:srgbClr val="3A3630"/>
-                </a:solidFill>
-                <a:latin typeface="Georgia"/>
-              </a:rPr>
-              <a:t>King, Roberta Rose, Jean Ngoya Kidula, James R. Krabill, and Thomas Oduro. Music in the Life of the African Church. Waco, TX: Baylor University Press, 2008.</a:t>
-            </a:r>
-          </a:p>
-          <a:p>
-            <a:pPr algn="l">
-              <a:lnSpc>
-                <a:spcPct val="120000"/>
-              </a:lnSpc>
-              <a:spcAft>
-                <a:spcPts val="400"/>
-              </a:spcAft>
-            </a:pPr>
-            <a:r>
-              <a:rPr sz="1100" b="1">
-                <a:solidFill>
-                  <a:srgbClr val="8A4B2A"/>
-                </a:solidFill>
-                <a:latin typeface="Calibri"/>
-              </a:rPr>
-              <a:t>7.  </a:t>
-            </a:r>
-            <a:r>
-              <a:rPr sz="1200">
-                <a:solidFill>
-                  <a:srgbClr val="3A3630"/>
-                </a:solidFill>
-                <a:latin typeface="Georgia"/>
-              </a:rPr>
-              <a:t>Rotimi, Oti Alaba. “The Role of Music in African Pentecostal Churches in Southwestern Nigeria.”</a:t>
-            </a:r>
-          </a:p>
-          <a:p>
-            <a:pPr algn="l">
-              <a:lnSpc>
-                <a:spcPct val="120000"/>
-              </a:lnSpc>
-              <a:spcAft>
-                <a:spcPts val="400"/>
-              </a:spcAft>
-            </a:pPr>
-            <a:r>
-              <a:rPr sz="1100" b="1">
-                <a:solidFill>
-                  <a:srgbClr val="8A4B2A"/>
-                </a:solidFill>
-                <a:latin typeface="Calibri"/>
-              </a:rPr>
-              <a:t>8.  </a:t>
-            </a:r>
-            <a:r>
-              <a:rPr sz="1200">
+              <a:rPr sz="1300">
                 <a:solidFill>
                   <a:srgbClr val="3A3630"/>
                 </a:solidFill>

</xml_diff>